<commit_message>
refactor(slides): simplify English wording and speaker notes in SOICT deck
</commit_message>
<xml_diff>
--- a/output/pdfs/SOICT2026_slides.pptx
+++ b/output/pdfs/SOICT2026_slides.pptx
@@ -524,7 +524,7 @@
           <a:lstStyle/>
           <a:p>
             <a:r>
-              <a:t>Good morning. I will show what a second edge board actually buys you when you split an ML intrusion detector across two Jetson Orin Nano Super devices, and what it costs in detection. Eight minutes, ﬁve results.</a:t>
+              <a:t>Good morning everyone. Today I will show what a second edge board actually adds when we split an ML intrusion detection system across two Jetson boards, and what it costs in detection. In eight minutes, I will share ﬁve key results.</a:t>
             </a:r>
           </a:p>
         </p:txBody>
@@ -594,7 +594,7 @@
           <a:lstStyle/>
           <a:p>
             <a:r>
-              <a:t>The JVM costs us more than three orders of magnitude, and that sets the roadmap. Batch size 10. If asked whether bigger batches ﬁx it: a Spark call costs about seven seconds whatever the batch, so the gap shrinks to about 27 times at ten thousand ﬂows, but a streaming IDS at 20 ﬂows per second would wait eight minutes to ﬁll such a batch.</a:t>
+              <a:t>We used PySpark for inference to match our distributed training pipeline. But on edge devices, the Spark JVM overhead is huge: taking 7.5 seconds per batch. Running the exact same model with ONNX Runtime is 7,200 times faster, at only 1.2 milliseconds. This clearly points to our future roadmap: train with Spark, but serve with ONNX or TensorRT.</a:t>
             </a:r>
           </a:p>
         </p:txBody>
@@ -664,7 +664,7 @@
           <a:lstStyle/>
           <a:p>
             <a:r>
-              <a:t>Recap: decoupling gives seven to nine times the load at a fraction of the energy. The price is about thirty percent of attacks skipped by the gate. On another dataset both detection and capacity fall, so a new network needs recalibration and retraining.</a:t>
+              <a:t>To summarize: First, decoupling the detection pipeline increases capacity by 7 to 9 times. Second, the trade-oﬀ is a 30 percent drop in recall at the gate. Third, cross-network de- ployment requires recalibrating the gate. And ﬁnally, lightweight serving engines like ONNX are critical for real-time edge IDS. Thank you for your attention, and I would be happy to answer your questions.</a:t>
             </a:r>
           </a:p>
         </p:txBody>
@@ -804,7 +804,7 @@
           <a:lstStyle/>
           <a:p>
             <a:r>
-              <a:t>Three gaps: single-device evaluation, energy never reported next to latency, and oﬄine numbers taken from leaky pipelines. Which model to deploy is the other half of the ques- tion. We attack all three with one system.</a:t>
+              <a:t>We see three big gaps in previous work: they only test on a single board, they rarely report energy together with latency, and oﬄine results often have data leakage. Our goal is to address all three on a real two-board cluster.</a:t>
             </a:r>
           </a:p>
         </p:txBody>
@@ -874,7 +874,7 @@
           <a:lstStyle/>
           <a:p>
             <a:r>
-              <a:t>We do not claim a new detector or a new distributed method. The contribution is the measurement: which placement pays, why, and what the gate costs in detection. The model we deploy is the one that survived a strict oﬄine audit.</a:t>
+              <a:t>To be clear, we do not claim a new machine learning model. Our main contribution is the empirical measurement: how to place the workload, how much speedup we get, and what the trade-oﬀ in detection is.</a:t>
             </a:r>
           </a:p>
         </p:txBody>
@@ -944,7 +944,7 @@
           <a:lstStyle/>
           <a:p>
             <a:r>
-              <a:t>Host runs the infrastructure. Board one gates, board two classiﬁes. Only suspicious ﬂows cross the Kafka topic between them. Everything is instrumented into Grafana.</a:t>
+              <a:t>Here is our system. The host PC runs the background services. Board one runs a lightweight autoencoder gate to ﬁlter benign traﬃc. Board two runs the heavy PySpark classiﬁer. Only suspicious ﬂows pass to Board two via Kafka. Everything is monitored in real time using Grafana.</a:t>
             </a:r>
           </a:p>
         </p:txBody>
@@ -1014,7 +1014,7 @@
           <a:lstStyle/>
           <a:p>
             <a:r>
-              <a:t>Latency is measured from the moment a ﬂow is sent to the moment its verdict is written, so time spent waiting in a queue counts. A fresh Kafka consumer group per run, so no run inherits another’s backlog.</a:t>
+              <a:t>We measure end-to-end latency: from the moment a ﬂow is sent until its ﬁnal verdict is saved, including queueing time. Each test uses a fresh Kafka group so no old messages remain.</a:t>
             </a:r>
           </a:p>
         </p:txBody>
@@ -1084,7 +1084,7 @@
           <a:lstStyle/>
           <a:p>
             <a:r>
-              <a:t>Single node and horizontal run with the gate oﬀ, as in the submitted version. Energy is measured at each mode’s sustained rate: 2.0, 2.0, 3.9, 9.5, 17.8 and 18.4 ﬂows per second. Tail latency is seconds in every mode because one PySpark batch takes seconds. A1 was measured in a later session with the same boards, models and replay ﬁle. At 30 ﬂows per second both repeats drained late, in 15 and 16 seconds. Gate skip is about 89 percent in every gated mode. Median latency in split mode is about one second. Single node plus gate: the 10 second rule puts it at 2.0 only because one repeat drained in 10.6 seconds. At 3 ﬂows per second it delivers 2.4 to 2.5 like the single node. Spark cluster: at 20 ﬂows per second one repeat kept up at 17.1 and the other did not, so its capacity is only known to lie between about 9 and 17.</a:t>
+              <a:t>Look at the table: Single node only handles 2.5 ﬂows per second. If we run the gate and classiﬁer as two separate processes on the SAME board, capacity jumps 7 times to 17.8 ﬂows per second, using only 0.32 Joules per ﬂow. Adding a second board pushes it to 22.4 ﬂows per second, but uses twice the energy. So the key insight: decoupling the pipeline gives the speedup, not just adding more hardware.</a:t>
             </a:r>
           </a:p>
         </p:txBody>
@@ -1154,7 +1154,7 @@
           <a:lstStyle/>
           <a:p>
             <a:r>
-              <a:t>Grafana at peak load during the full replay. About one versus ninety-ﬁve percent. The asymmetry is the whole argument for the split. Add: the gate is a tunable ﬁlter, not a ﬁxed point — backup slide has the operating curve.</a:t>
+              <a:t>This Grafana screenshot shows the system at peak load. Notice the huge contrast: Board one uses only 1.3 percent CPU, while Board two reaches 94.5 percent. This extreme asym- metry is why splitting the stages is so eﬀective.</a:t>
             </a:r>
           </a:p>
         </p:txBody>
@@ -1224,7 +1224,7 @@
           <a:lstStyle/>
           <a:p>
             <a:r>
-              <a:t>The reviewers asked for exactly this: precision, recall and F1 of the whole deployed pipeline, not the oﬄine classiﬁer. The deployed threshold is the 0.995 quantile of benign validation errors, ﬁxed before any test. The capacity-window rows overlap because every window replays the sample from its ﬁrst row. The full replay covers every ﬂow once.</a:t>
+              <a:t>What is the trade-oﬀ? High throughput costs recall. Precision is 100 percent with zero false alarms. But recall drops to 69.5 percent. Notice that every missed attack was skipped by the gate; the classiﬁer made zero errors on what it received. So the gate threshold directly controls this trade-oﬀ.</a:t>
             </a:r>
           </a:p>
         </p:txBody>
@@ -1294,7 +1294,7 @@
           <a:lstStyle/>
           <a:p>
             <a:r>
-              <a:t>Reviewer one asked for a second dataset, so we replayed CSE-CIC-IDS2018 through the deployed boards without retraining. Capacity is not a property of the pipeline alone: the gate’s skip ratio depends on the traﬃc, and with it the load on the classiﬁer. At 12 ﬂows per second both repeats drained late, in 19 and 29 seconds. The oﬄine cross-dataset study, 18 runs, gives AUC-PR 0.48 from 2017 to 2018 and 0.19 the other way.</a:t>
+              <a:t>When we test on another dataset, CSE-CIC-IDS2018, without retraining: capacity drops from 22 to 8 ﬂows per second, and recall drops to under 1 percent. Why? Because normal traﬃc from a new network looks strange to the gate, sending 30 percent of ﬂows to the classiﬁer instead of 11. So for a new network, we must recalibrate the gate and retrain the classiﬁer.</a:t>
             </a:r>
           </a:p>
         </p:txBody>

</xml_diff>